<commit_message>
Corrections avant soutenance : mise en forme conditionnelle, libelles des visuels, intervalle de confiance, captures et README
</commit_message>
<xml_diff>
--- a/05_Restitution/Garanteo_Restitution.pptx
+++ b/05_Restitution/Garanteo_Restitution.pptx
@@ -1345,7 +1345,7 @@
           <a:lstStyle/>
           <a:p>
             <a:r>
-              <a:t>11:00 — La consigne demande de montrer l'interactivité des visuels. Voilà les trois captures : le même écran avec la règle du premier contact, puis du dernier contact — le classement bascule sous vos yeux — et l'infobulle au survol d'une campagne.</a:t>
+              <a:t>11:00 — La consigne demande de montrer l'interactivité des visuels. Voilà trois captures du même écran, à un clic d'intervalle : premier contact, dernier contact, multi-touch. Le classement bascule sous vos yeux, et les couleurs avec lui. acb1a5969d passe de la plus chère à 700 € à la moins chère à 175 €, sans qu'un seul euro de budget ait bougé. En multi-touch tout devient vert, parce que cette règle attribue 554 clients pour 180 réels : elle sert de contrôle, jamais de base de décision. Je vous montrerai aussi l'infobulle en direct.</a:t>
             </a:r>
           </a:p>
           <a:p>
@@ -2529,7 +2529,7 @@
           <a:p>
             <a:fld id="{5BCAD085-E8A6-8845-BD4E-CB4CCA059FC4}" type="datetimeFigureOut">
               <a:rPr lang="en-US" smtClean="0"/>
-              <a:t>8/25/2026</a:t>
+              <a:t>8/27/2026</a:t>
             </a:fld>
             <a:endParaRPr lang="en-US"/>
           </a:p>
@@ -2697,7 +2697,7 @@
           <a:p>
             <a:fld id="{5BCAD085-E8A6-8845-BD4E-CB4CCA059FC4}" type="datetimeFigureOut">
               <a:rPr lang="en-US" smtClean="0"/>
-              <a:t>8/25/2026</a:t>
+              <a:t>8/27/2026</a:t>
             </a:fld>
             <a:endParaRPr lang="en-US"/>
           </a:p>
@@ -2875,7 +2875,7 @@
           <a:p>
             <a:fld id="{5BCAD085-E8A6-8845-BD4E-CB4CCA059FC4}" type="datetimeFigureOut">
               <a:rPr lang="en-US" smtClean="0"/>
-              <a:t>8/25/2026</a:t>
+              <a:t>8/27/2026</a:t>
             </a:fld>
             <a:endParaRPr lang="en-US"/>
           </a:p>
@@ -3043,7 +3043,7 @@
           <a:p>
             <a:fld id="{5BCAD085-E8A6-8845-BD4E-CB4CCA059FC4}" type="datetimeFigureOut">
               <a:rPr lang="en-US" smtClean="0"/>
-              <a:t>8/25/2026</a:t>
+              <a:t>8/27/2026</a:t>
             </a:fld>
             <a:endParaRPr lang="en-US"/>
           </a:p>
@@ -3288,7 +3288,7 @@
           <a:p>
             <a:fld id="{5BCAD085-E8A6-8845-BD4E-CB4CCA059FC4}" type="datetimeFigureOut">
               <a:rPr lang="en-US" smtClean="0"/>
-              <a:t>8/25/2026</a:t>
+              <a:t>8/27/2026</a:t>
             </a:fld>
             <a:endParaRPr lang="en-US"/>
           </a:p>
@@ -3573,7 +3573,7 @@
           <a:p>
             <a:fld id="{5BCAD085-E8A6-8845-BD4E-CB4CCA059FC4}" type="datetimeFigureOut">
               <a:rPr lang="en-US" smtClean="0"/>
-              <a:t>8/25/2026</a:t>
+              <a:t>8/27/2026</a:t>
             </a:fld>
             <a:endParaRPr lang="en-US"/>
           </a:p>
@@ -3992,7 +3992,7 @@
           <a:p>
             <a:fld id="{5BCAD085-E8A6-8845-BD4E-CB4CCA059FC4}" type="datetimeFigureOut">
               <a:rPr lang="en-US" smtClean="0"/>
-              <a:t>8/25/2026</a:t>
+              <a:t>8/27/2026</a:t>
             </a:fld>
             <a:endParaRPr lang="en-US"/>
           </a:p>
@@ -4109,7 +4109,7 @@
           <a:p>
             <a:fld id="{5BCAD085-E8A6-8845-BD4E-CB4CCA059FC4}" type="datetimeFigureOut">
               <a:rPr lang="en-US" smtClean="0"/>
-              <a:t>8/25/2026</a:t>
+              <a:t>8/27/2026</a:t>
             </a:fld>
             <a:endParaRPr lang="en-US"/>
           </a:p>
@@ -4204,7 +4204,7 @@
           <a:p>
             <a:fld id="{5BCAD085-E8A6-8845-BD4E-CB4CCA059FC4}" type="datetimeFigureOut">
               <a:rPr lang="en-US" smtClean="0"/>
-              <a:t>8/25/2026</a:t>
+              <a:t>8/27/2026</a:t>
             </a:fld>
             <a:endParaRPr lang="en-US"/>
           </a:p>
@@ -4479,7 +4479,7 @@
           <a:p>
             <a:fld id="{5BCAD085-E8A6-8845-BD4E-CB4CCA059FC4}" type="datetimeFigureOut">
               <a:rPr lang="en-US" smtClean="0"/>
-              <a:t>8/25/2026</a:t>
+              <a:t>8/27/2026</a:t>
             </a:fld>
             <a:endParaRPr lang="en-US"/>
           </a:p>
@@ -4731,7 +4731,7 @@
           <a:p>
             <a:fld id="{5BCAD085-E8A6-8845-BD4E-CB4CCA059FC4}" type="datetimeFigureOut">
               <a:rPr lang="en-US" smtClean="0"/>
-              <a:t>8/25/2026</a:t>
+              <a:t>8/27/2026</a:t>
             </a:fld>
             <a:endParaRPr lang="en-US"/>
           </a:p>
@@ -4942,7 +4942,7 @@
           <a:p>
             <a:fld id="{5BCAD085-E8A6-8845-BD4E-CB4CCA059FC4}" type="datetimeFigureOut">
               <a:rPr lang="en-US" smtClean="0"/>
-              <a:t>8/25/2026</a:t>
+              <a:t>8/27/2026</a:t>
             </a:fld>
             <a:endParaRPr lang="en-US"/>
           </a:p>
@@ -5512,7 +5512,7 @@
         </p:spPr>
         <p:txBody>
           <a:bodyPr wrap="square" lIns="0" tIns="0" rIns="0" bIns="0" anchor="t">
-            <a:normAutofit/>
+            <a:normAutofit fontScale="92500" lnSpcReduction="20000"/>
           </a:bodyPr>
           <a:lstStyle/>
           <a:p>
@@ -5717,7 +5717,7 @@
         </p:spPr>
         <p:txBody>
           <a:bodyPr wrap="square" lIns="0" tIns="0" rIns="0" bIns="0" anchor="t">
-            <a:normAutofit/>
+            <a:normAutofit lnSpcReduction="10000"/>
           </a:bodyPr>
           <a:lstStyle/>
           <a:p>
@@ -5969,7 +5969,7 @@
         </p:spPr>
         <p:txBody>
           <a:bodyPr wrap="square" lIns="0" tIns="0" rIns="0" bIns="0" anchor="t">
-            <a:normAutofit/>
+            <a:normAutofit fontScale="92500" lnSpcReduction="10000"/>
           </a:bodyPr>
           <a:lstStyle/>
           <a:p>
@@ -10772,7 +10772,7 @@
         </p:spPr>
         <p:txBody>
           <a:bodyPr wrap="square" lIns="0" tIns="0" rIns="0" bIns="0" anchor="t">
-            <a:normAutofit/>
+            <a:normAutofit lnSpcReduction="10000"/>
           </a:bodyPr>
           <a:lstStyle/>
           <a:p>
@@ -11895,7 +11895,7 @@
         </p:spPr>
         <p:txBody>
           <a:bodyPr wrap="square" lIns="0" tIns="0" rIns="0" bIns="0" anchor="t">
-            <a:normAutofit/>
+            <a:normAutofit lnSpcReduction="10000"/>
           </a:bodyPr>
           <a:lstStyle/>
           <a:p>
@@ -12002,7 +12002,7 @@
         </p:spPr>
         <p:txBody>
           <a:bodyPr wrap="square" lIns="0" tIns="0" rIns="0" bIns="0" anchor="t">
-            <a:normAutofit/>
+            <a:normAutofit fontScale="92500"/>
           </a:bodyPr>
           <a:lstStyle/>
           <a:p>
@@ -12044,7 +12044,7 @@
           <p:nvPr/>
         </p:nvPicPr>
         <p:blipFill>
-          <a:blip r:embed="rId4"/>
+          <a:blip r:embed="rId3"/>
           <a:stretch>
             <a:fillRect/>
           </a:stretch>
@@ -12563,7 +12563,7 @@
         </p:spPr>
         <p:txBody>
           <a:bodyPr wrap="square" lIns="0" tIns="0" rIns="0" bIns="0" anchor="t">
-            <a:normAutofit/>
+            <a:normAutofit lnSpcReduction="10000"/>
           </a:bodyPr>
           <a:lstStyle/>
           <a:p>
@@ -12998,7 +12998,7 @@
         </p:spPr>
         <p:txBody>
           <a:bodyPr wrap="square" lIns="0" tIns="0" rIns="0" bIns="0" anchor="t">
-            <a:normAutofit/>
+            <a:normAutofit fontScale="92500" lnSpcReduction="10000"/>
           </a:bodyPr>
           <a:lstStyle/>
           <a:p>
@@ -17419,14 +17419,14 @@
                 </a:solidFill>
                 <a:latin typeface="Segoe UI"/>
               </a:rPr>
-              <a:t>Infobulle au survol</a:t>
+              <a:t>Segment « multi-touch »</a:t>
             </a:r>
           </a:p>
         </p:txBody>
       </p:sp>
       <p:pic>
         <p:nvPicPr>
-          <p:cNvPr id="21" name="Picture 20" descr="1_premier_contact.png"/>
+          <p:cNvPr id="21" name="Picture 20" descr="Page 2 du dashboard, segment réglé sur premier contact"/>
           <p:cNvPicPr>
             <a:picLocks noChangeAspect="1"/>
           </p:cNvPicPr>
@@ -17455,7 +17455,7 @@
       </p:pic>
       <p:pic>
         <p:nvPicPr>
-          <p:cNvPr id="22" name="Picture 21" descr="2_dernier_contact.png"/>
+          <p:cNvPr id="22" name="Picture 21" descr="Page 2 du dashboard, segment réglé sur dernier contact"/>
           <p:cNvPicPr>
             <a:picLocks noChangeAspect="1"/>
           </p:cNvPicPr>
@@ -17484,7 +17484,7 @@
       </p:pic>
       <p:pic>
         <p:nvPicPr>
-          <p:cNvPr id="23" name="Picture 22" descr="3_infobulle.png"/>
+          <p:cNvPr id="23" name="Picture 22" descr="Page 2 du dashboard, segment réglé sur multi-touch"/>
           <p:cNvPicPr>
             <a:picLocks noChangeAspect="1"/>
           </p:cNvPicPr>
@@ -17554,6 +17554,7 @@
           <a:lstStyle/>
           <a:p>
             <a:pPr algn="ctr"/>
+            <a:endParaRPr/>
           </a:p>
         </p:txBody>
       </p:sp>
@@ -17574,8 +17575,8 @@
           <a:noFill/>
         </p:spPr>
         <p:txBody>
-          <a:bodyPr wrap="square" anchor="t" lIns="0" rIns="0" tIns="0" bIns="0">
-            <a:normAutofit/>
+          <a:bodyPr wrap="square" lIns="0" tIns="0" rIns="0" bIns="0" anchor="t">
+            <a:normAutofit fontScale="92500"/>
           </a:bodyPr>
           <a:lstStyle/>
           <a:p>
@@ -17603,7 +17604,7 @@
                 </a:solidFill>
                 <a:latin typeface="Segoe UI"/>
               </a:rPr>
-              <a:t>les deux premières captures montrent le même écran à un clic d'intervalle, et le classement des campagnes a changé. La troisième montre la page d'infobulle qui s'ouvre au survol d'une campagne.</a:t>
+              <a:t>les trois captures montrent le même écran à un clic d'intervalle. Le classement s'inverse et les couleurs suivent : acb1a5969d passe de la plus chère à 700 € à la moins chère à 175 €. En multi-touch, tout passe au vert, parce que cette règle attribue 554 clients pour 180 réels.</a:t>
             </a:r>
           </a:p>
         </p:txBody>
@@ -17741,7 +17742,7 @@
         </p:spPr>
         <p:txBody>
           <a:bodyPr wrap="square" lIns="0" tIns="0" rIns="0" bIns="0" anchor="t">
-            <a:normAutofit/>
+            <a:normAutofit fontScale="92500" lnSpcReduction="10000"/>
           </a:bodyPr>
           <a:lstStyle/>
           <a:p>
@@ -23439,7 +23440,7 @@
         </p:spPr>
         <p:txBody>
           <a:bodyPr wrap="square" lIns="0" tIns="0" rIns="0" bIns="0" anchor="t">
-            <a:normAutofit/>
+            <a:normAutofit fontScale="92500" lnSpcReduction="10000"/>
           </a:bodyPr>
           <a:lstStyle/>
           <a:p>
@@ -31123,7 +31124,7 @@
         </p:spPr>
         <p:txBody>
           <a:bodyPr wrap="square" lIns="0" tIns="0" rIns="0" bIns="0" anchor="t">
-            <a:normAutofit/>
+            <a:normAutofit fontScale="92500" lnSpcReduction="10000"/>
           </a:bodyPr>
           <a:lstStyle/>
           <a:p>
@@ -37928,7 +37929,7 @@
         </p:spPr>
         <p:txBody>
           <a:bodyPr wrap="square" lIns="0" tIns="0" rIns="0" bIns="0" anchor="t">
-            <a:normAutofit/>
+            <a:normAutofit fontScale="92500" lnSpcReduction="10000"/>
           </a:bodyPr>
           <a:lstStyle/>
           <a:p>
@@ -39754,7 +39755,7 @@
         </p:spPr>
         <p:txBody>
           <a:bodyPr wrap="square" lIns="0" tIns="0" rIns="0" bIns="0" anchor="t">
-            <a:normAutofit/>
+            <a:normAutofit lnSpcReduction="10000"/>
           </a:bodyPr>
           <a:lstStyle/>
           <a:p>
@@ -39852,7 +39853,7 @@
           <p:nvPr/>
         </p:nvPicPr>
         <p:blipFill>
-          <a:blip r:embed="rId4"/>
+          <a:blip r:embed="rId3"/>
           <a:stretch>
             <a:fillRect/>
           </a:stretch>

</xml_diff>